<commit_message>
Adding middlware details to the code
</commit_message>
<xml_diff>
--- a/Microsoft Agent Framework.pptx
+++ b/Microsoft Agent Framework.pptx
@@ -6,7 +6,7 @@
     <p:sldMasterId id="2147483662" r:id="rId2"/>
   </p:sldMasterIdLst>
   <p:notesMasterIdLst>
-    <p:notesMasterId r:id="rId16"/>
+    <p:notesMasterId r:id="rId17"/>
   </p:notesMasterIdLst>
   <p:sldIdLst>
     <p:sldId id="256" r:id="rId3"/>
@@ -21,7 +21,8 @@
     <p:sldId id="447" r:id="rId12"/>
     <p:sldId id="463" r:id="rId13"/>
     <p:sldId id="464" r:id="rId14"/>
-    <p:sldId id="473" r:id="rId15"/>
+    <p:sldId id="476" r:id="rId15"/>
+    <p:sldId id="473" r:id="rId16"/>
   </p:sldIdLst>
   <p:sldSz cx="12192000" cy="6858000"/>
   <p:notesSz cx="6858000" cy="9144000"/>
@@ -120,6 +121,11 @@
       </a:defRPr>
     </a:lvl9pPr>
   </p:defaultTextStyle>
+  <p:extLst>
+    <p:ext uri="{EFAFB233-063F-42B5-8137-9DF3F51BA10A}">
+      <p15:sldGuideLst xmlns:p15="http://schemas.microsoft.com/office/powerpoint/2012/main"/>
+    </p:ext>
+  </p:extLst>
 </p:presentation>
 </file>
 
@@ -205,7 +211,7 @@
           <a:p>
             <a:fld id="{05C02510-270C-494D-A8D0-193A3EB52C09}" type="datetimeFigureOut">
               <a:rPr lang="en-IN" smtClean="0"/>
-              <a:t>14-04-2026</a:t>
+              <a:t>20-04-2026</a:t>
             </a:fld>
             <a:endParaRPr lang="en-IN"/>
           </a:p>
@@ -2083,7 +2089,7 @@
           <a:p>
             <a:fld id="{CE8335A2-7F5B-480A-91D3-B4A6105BFEAD}" type="datetimeFigureOut">
               <a:rPr lang="en-IN" smtClean="0"/>
-              <a:t>18-04-2026</a:t>
+              <a:t>20-04-2026</a:t>
             </a:fld>
             <a:endParaRPr lang="en-IN"/>
           </a:p>
@@ -2283,7 +2289,7 @@
           <a:p>
             <a:fld id="{CE8335A2-7F5B-480A-91D3-B4A6105BFEAD}" type="datetimeFigureOut">
               <a:rPr lang="en-IN" smtClean="0"/>
-              <a:t>18-04-2026</a:t>
+              <a:t>20-04-2026</a:t>
             </a:fld>
             <a:endParaRPr lang="en-IN"/>
           </a:p>
@@ -2493,7 +2499,7 @@
           <a:p>
             <a:fld id="{CE8335A2-7F5B-480A-91D3-B4A6105BFEAD}" type="datetimeFigureOut">
               <a:rPr lang="en-IN" smtClean="0"/>
-              <a:t>18-04-2026</a:t>
+              <a:t>20-04-2026</a:t>
             </a:fld>
             <a:endParaRPr lang="en-IN"/>
           </a:p>
@@ -2715,7 +2721,7 @@
           <a:p>
             <a:fld id="{CE8335A2-7F5B-480A-91D3-B4A6105BFEAD}" type="datetimeFigureOut">
               <a:rPr lang="en-IN" smtClean="0"/>
-              <a:t>18-04-2026</a:t>
+              <a:t>20-04-2026</a:t>
             </a:fld>
             <a:endParaRPr lang="en-IN"/>
           </a:p>
@@ -2915,7 +2921,7 @@
           <a:p>
             <a:fld id="{CE8335A2-7F5B-480A-91D3-B4A6105BFEAD}" type="datetimeFigureOut">
               <a:rPr lang="en-IN" smtClean="0"/>
-              <a:t>18-04-2026</a:t>
+              <a:t>20-04-2026</a:t>
             </a:fld>
             <a:endParaRPr lang="en-IN"/>
           </a:p>
@@ -3191,7 +3197,7 @@
           <a:p>
             <a:fld id="{CE8335A2-7F5B-480A-91D3-B4A6105BFEAD}" type="datetimeFigureOut">
               <a:rPr lang="en-IN" smtClean="0"/>
-              <a:t>18-04-2026</a:t>
+              <a:t>20-04-2026</a:t>
             </a:fld>
             <a:endParaRPr lang="en-IN"/>
           </a:p>
@@ -3459,7 +3465,7 @@
           <a:p>
             <a:fld id="{CE8335A2-7F5B-480A-91D3-B4A6105BFEAD}" type="datetimeFigureOut">
               <a:rPr lang="en-IN" smtClean="0"/>
-              <a:t>18-04-2026</a:t>
+              <a:t>20-04-2026</a:t>
             </a:fld>
             <a:endParaRPr lang="en-IN"/>
           </a:p>
@@ -3874,7 +3880,7 @@
           <a:p>
             <a:fld id="{CE8335A2-7F5B-480A-91D3-B4A6105BFEAD}" type="datetimeFigureOut">
               <a:rPr lang="en-IN" smtClean="0"/>
-              <a:t>18-04-2026</a:t>
+              <a:t>20-04-2026</a:t>
             </a:fld>
             <a:endParaRPr lang="en-IN"/>
           </a:p>
@@ -4016,7 +4022,7 @@
           <a:p>
             <a:fld id="{CE8335A2-7F5B-480A-91D3-B4A6105BFEAD}" type="datetimeFigureOut">
               <a:rPr lang="en-IN" smtClean="0"/>
-              <a:t>18-04-2026</a:t>
+              <a:t>20-04-2026</a:t>
             </a:fld>
             <a:endParaRPr lang="en-IN"/>
           </a:p>
@@ -4129,7 +4135,7 @@
           <a:p>
             <a:fld id="{CE8335A2-7F5B-480A-91D3-B4A6105BFEAD}" type="datetimeFigureOut">
               <a:rPr lang="en-IN" smtClean="0"/>
-              <a:t>18-04-2026</a:t>
+              <a:t>20-04-2026</a:t>
             </a:fld>
             <a:endParaRPr lang="en-IN"/>
           </a:p>
@@ -4442,7 +4448,7 @@
           <a:p>
             <a:fld id="{CE8335A2-7F5B-480A-91D3-B4A6105BFEAD}" type="datetimeFigureOut">
               <a:rPr lang="en-IN" smtClean="0"/>
-              <a:t>18-04-2026</a:t>
+              <a:t>20-04-2026</a:t>
             </a:fld>
             <a:endParaRPr lang="en-IN"/>
           </a:p>
@@ -4972,7 +4978,7 @@
           <a:p>
             <a:fld id="{CE8335A2-7F5B-480A-91D3-B4A6105BFEAD}" type="datetimeFigureOut">
               <a:rPr lang="en-IN" smtClean="0"/>
-              <a:t>18-04-2026</a:t>
+              <a:t>20-04-2026</a:t>
             </a:fld>
             <a:endParaRPr lang="en-IN"/>
           </a:p>
@@ -10313,6 +10319,1717 @@
 </file>
 
 <file path=ppt/slides/slide13.xml><?xml version="1.0" encoding="utf-8"?>
+<p:sld xmlns:a="http://schemas.openxmlformats.org/drawingml/2006/main" xmlns:r="http://schemas.openxmlformats.org/officeDocument/2006/relationships" xmlns:p="http://schemas.openxmlformats.org/presentationml/2006/main">
+  <p:cSld>
+    <p:spTree>
+      <p:nvGrpSpPr>
+        <p:cNvPr id="1" name=""/>
+        <p:cNvGrpSpPr/>
+        <p:nvPr/>
+      </p:nvGrpSpPr>
+      <p:grpSpPr>
+        <a:xfrm>
+          <a:off x="0" y="0"/>
+          <a:ext cx="0" cy="0"/>
+          <a:chOff x="0" y="0"/>
+          <a:chExt cx="0" cy="0"/>
+        </a:xfrm>
+      </p:grpSpPr>
+      <p:sp>
+        <p:nvSpPr>
+          <p:cNvPr id="100" name="HeaderBg"/>
+          <p:cNvSpPr>
+            <a:spLocks noGrp="1"/>
+          </p:cNvSpPr>
+          <p:nvPr/>
+        </p:nvSpPr>
+        <p:spPr>
+          <a:xfrm>
+            <a:off x="0" y="0"/>
+            <a:ext cx="12192000" cy="1219200"/>
+          </a:xfrm>
+          <a:prstGeom prst="rect">
+            <a:avLst/>
+          </a:prstGeom>
+          <a:solidFill>
+            <a:srgbClr val="0F1F3D"/>
+          </a:solidFill>
+          <a:ln>
+            <a:noFill/>
+          </a:ln>
+        </p:spPr>
+        <p:txBody>
+          <a:bodyPr vert="horz" lIns="91440" tIns="45720" rIns="91440" bIns="45720" anchor="ctr"/>
+          <a:lstStyle/>
+          <a:p>
+            <a:endParaRPr lang="en-US" dirty="0"/>
+          </a:p>
+        </p:txBody>
+      </p:sp>
+      <p:sp>
+        <p:nvSpPr>
+          <p:cNvPr id="101" name="AccentStripe"/>
+          <p:cNvSpPr>
+            <a:spLocks noGrp="1"/>
+          </p:cNvSpPr>
+          <p:nvPr/>
+        </p:nvSpPr>
+        <p:spPr>
+          <a:xfrm>
+            <a:off x="0" y="0"/>
+            <a:ext cx="266700" cy="1219200"/>
+          </a:xfrm>
+          <a:prstGeom prst="rect">
+            <a:avLst/>
+          </a:prstGeom>
+          <a:solidFill>
+            <a:srgbClr val="0078D4"/>
+          </a:solidFill>
+          <a:ln>
+            <a:noFill/>
+          </a:ln>
+        </p:spPr>
+        <p:txBody>
+          <a:bodyPr vert="horz" lIns="91440" tIns="45720" rIns="91440" bIns="45720" anchor="ctr"/>
+          <a:lstStyle/>
+          <a:p>
+            <a:endParaRPr lang="en-US" dirty="0"/>
+          </a:p>
+        </p:txBody>
+      </p:sp>
+      <p:sp>
+        <p:nvSpPr>
+          <p:cNvPr id="102" name="Title"/>
+          <p:cNvSpPr>
+            <a:spLocks noGrp="1"/>
+          </p:cNvSpPr>
+          <p:nvPr/>
+        </p:nvSpPr>
+        <p:spPr>
+          <a:xfrm>
+            <a:off x="546100" y="139700"/>
+            <a:ext cx="11087100" cy="635000"/>
+          </a:xfrm>
+          <a:prstGeom prst="rect">
+            <a:avLst/>
+          </a:prstGeom>
+          <a:noFill/>
+          <a:ln>
+            <a:noFill/>
+          </a:ln>
+        </p:spPr>
+        <p:txBody>
+          <a:bodyPr vert="horz" lIns="91440" tIns="45720" rIns="91440" bIns="45720" anchor="ctr"/>
+          <a:lstStyle/>
+          <a:p>
+            <a:r>
+              <a:rPr lang="en-US" sz="3067" b="1" dirty="0">
+                <a:solidFill>
+                  <a:srgbClr val="FFFFFF"/>
+                </a:solidFill>
+                <a:latin typeface="Calibri" pitchFamily="34" charset="0"/>
+              </a:rPr>
+              <a:t>Middleware</a:t>
+            </a:r>
+          </a:p>
+        </p:txBody>
+      </p:sp>
+      <p:sp>
+        <p:nvSpPr>
+          <p:cNvPr id="103" name="Subtitle"/>
+          <p:cNvSpPr>
+            <a:spLocks noGrp="1"/>
+          </p:cNvSpPr>
+          <p:nvPr/>
+        </p:nvSpPr>
+        <p:spPr>
+          <a:xfrm>
+            <a:off x="546100" y="812800"/>
+            <a:ext cx="11087100" cy="342900"/>
+          </a:xfrm>
+          <a:prstGeom prst="rect">
+            <a:avLst/>
+          </a:prstGeom>
+          <a:noFill/>
+          <a:ln>
+            <a:noFill/>
+          </a:ln>
+        </p:spPr>
+        <p:txBody>
+          <a:bodyPr vert="horz" lIns="91440" tIns="45720" rIns="91440" bIns="45720" anchor="ctr"/>
+          <a:lstStyle/>
+          <a:p>
+            <a:r>
+              <a:rPr lang="en-US" sz="1467" i="1" dirty="0">
+                <a:solidFill>
+                  <a:srgbClr val="C7E0F4"/>
+                </a:solidFill>
+                <a:latin typeface="Calibri" pitchFamily="34" charset="0"/>
+              </a:rPr>
+              <a:t>Intercept, modify, and enhance agent interactions at every layer of execution</a:t>
+            </a:r>
+          </a:p>
+        </p:txBody>
+      </p:sp>
+      <p:sp>
+        <p:nvSpPr>
+          <p:cNvPr id="104" name="WhyBg"/>
+          <p:cNvSpPr>
+            <a:spLocks noGrp="1"/>
+          </p:cNvSpPr>
+          <p:nvPr/>
+        </p:nvSpPr>
+        <p:spPr>
+          <a:xfrm>
+            <a:off x="342900" y="1333500"/>
+            <a:ext cx="11518900" cy="1206500"/>
+          </a:xfrm>
+          <a:prstGeom prst="rect">
+            <a:avLst/>
+          </a:prstGeom>
+          <a:solidFill>
+            <a:srgbClr val="E8F0FE"/>
+          </a:solidFill>
+          <a:ln>
+            <a:noFill/>
+          </a:ln>
+        </p:spPr>
+        <p:txBody>
+          <a:bodyPr vert="horz" lIns="91440" tIns="45720" rIns="91440" bIns="45720" anchor="ctr"/>
+          <a:lstStyle/>
+          <a:p>
+            <a:endParaRPr lang="en-US" dirty="0"/>
+          </a:p>
+        </p:txBody>
+      </p:sp>
+      <p:sp>
+        <p:nvSpPr>
+          <p:cNvPr id="105" name="WhyAccent"/>
+          <p:cNvSpPr>
+            <a:spLocks noGrp="1"/>
+          </p:cNvSpPr>
+          <p:nvPr/>
+        </p:nvSpPr>
+        <p:spPr>
+          <a:xfrm>
+            <a:off x="342900" y="1333500"/>
+            <a:ext cx="88900" cy="1206500"/>
+          </a:xfrm>
+          <a:prstGeom prst="rect">
+            <a:avLst/>
+          </a:prstGeom>
+          <a:solidFill>
+            <a:srgbClr val="0078D4"/>
+          </a:solidFill>
+          <a:ln>
+            <a:noFill/>
+          </a:ln>
+        </p:spPr>
+        <p:txBody>
+          <a:bodyPr vert="horz" lIns="91440" tIns="45720" rIns="91440" bIns="45720" anchor="ctr"/>
+          <a:lstStyle/>
+          <a:p>
+            <a:endParaRPr lang="en-US" dirty="0"/>
+          </a:p>
+        </p:txBody>
+      </p:sp>
+      <p:sp>
+        <p:nvSpPr>
+          <p:cNvPr id="106" name="WhyText"/>
+          <p:cNvSpPr>
+            <a:spLocks noGrp="1"/>
+          </p:cNvSpPr>
+          <p:nvPr/>
+        </p:nvSpPr>
+        <p:spPr>
+          <a:xfrm>
+            <a:off x="546100" y="1384300"/>
+            <a:ext cx="5334000" cy="1066800"/>
+          </a:xfrm>
+          <a:prstGeom prst="rect">
+            <a:avLst/>
+          </a:prstGeom>
+          <a:noFill/>
+          <a:ln>
+            <a:noFill/>
+          </a:ln>
+        </p:spPr>
+        <p:txBody>
+          <a:bodyPr vert="horz" lIns="91440" tIns="45720" rIns="91440" bIns="45720" anchor="ctr"/>
+          <a:lstStyle/>
+          <a:p>
+            <a:pPr>
+              <a:spcBef>
+                <a:spcPts val="0"/>
+              </a:spcBef>
+              <a:buNone/>
+            </a:pPr>
+            <a:r>
+              <a:rPr lang="en-US" sz="1200" b="1" dirty="0">
+                <a:solidFill>
+                  <a:srgbClr val="0078D4"/>
+                </a:solidFill>
+                <a:latin typeface="Calibri" pitchFamily="34" charset="0"/>
+              </a:rPr>
+              <a:t>What is Middleware?</a:t>
+            </a:r>
+          </a:p>
+          <a:p>
+            <a:pPr>
+              <a:spcBef>
+                <a:spcPts val="150"/>
+              </a:spcBef>
+              <a:buNone/>
+            </a:pPr>
+            <a:r>
+              <a:rPr lang="en-US" sz="1000" dirty="0">
+                <a:solidFill>
+                  <a:srgbClr val="4A5568"/>
+                </a:solidFill>
+                <a:latin typeface="Calibri" pitchFamily="34" charset="0"/>
+              </a:rPr>
+              <a:t>A pipeline of functions that wrap agent runs, function calls, and LLM requests — enabling cross-cutting concerns without touching core logic.</a:t>
+            </a:r>
+          </a:p>
+        </p:txBody>
+      </p:sp>
+      <p:sp>
+        <p:nvSpPr>
+          <p:cNvPr id="110" name="LoopBg"/>
+          <p:cNvSpPr>
+            <a:spLocks noGrp="1"/>
+          </p:cNvSpPr>
+          <p:nvPr/>
+        </p:nvSpPr>
+        <p:spPr>
+          <a:xfrm>
+            <a:off x="342900" y="2667000"/>
+            <a:ext cx="11518900" cy="1460500"/>
+          </a:xfrm>
+          <a:prstGeom prst="rect">
+            <a:avLst/>
+          </a:prstGeom>
+          <a:solidFill>
+            <a:srgbClr val="F0F5FA"/>
+          </a:solidFill>
+          <a:ln>
+            <a:noFill/>
+          </a:ln>
+        </p:spPr>
+        <p:txBody>
+          <a:bodyPr vert="horz" lIns="91440" tIns="45720" rIns="91440" bIns="45720" anchor="ctr"/>
+          <a:lstStyle/>
+          <a:p>
+            <a:endParaRPr lang="en-US" dirty="0"/>
+          </a:p>
+        </p:txBody>
+      </p:sp>
+      <p:sp>
+        <p:nvSpPr>
+          <p:cNvPr id="111" name="LoopTitle"/>
+          <p:cNvSpPr>
+            <a:spLocks noGrp="1"/>
+          </p:cNvSpPr>
+          <p:nvPr/>
+        </p:nvSpPr>
+        <p:spPr>
+          <a:xfrm>
+            <a:off x="546100" y="2730500"/>
+            <a:ext cx="6350000" cy="254000"/>
+          </a:xfrm>
+          <a:prstGeom prst="rect">
+            <a:avLst/>
+          </a:prstGeom>
+          <a:noFill/>
+          <a:ln>
+            <a:noFill/>
+          </a:ln>
+        </p:spPr>
+        <p:txBody>
+          <a:bodyPr vert="horz" lIns="91440" tIns="45720" rIns="91440" bIns="45720" anchor="ctr"/>
+          <a:lstStyle/>
+          <a:p>
+            <a:r>
+              <a:rPr lang="en-US" sz="1467" b="1" dirty="0">
+                <a:solidFill>
+                  <a:srgbClr val="0078D4"/>
+                </a:solidFill>
+                <a:latin typeface="Calibri" pitchFamily="34" charset="0"/>
+              </a:rPr>
+              <a:t>3 Middleware Types — Execution Pipeline</a:t>
+            </a:r>
+          </a:p>
+        </p:txBody>
+      </p:sp>
+      <p:sp>
+        <p:nvSpPr>
+          <p:cNvPr id="120" name="Flow0"/>
+          <p:cNvSpPr>
+            <a:spLocks noGrp="1"/>
+          </p:cNvSpPr>
+          <p:nvPr/>
+        </p:nvSpPr>
+        <p:spPr>
+          <a:xfrm>
+            <a:off x="546100" y="3048000"/>
+            <a:ext cx="1625600" cy="762000"/>
+          </a:xfrm>
+          <a:prstGeom prst="rect">
+            <a:avLst/>
+          </a:prstGeom>
+          <a:solidFill>
+            <a:srgbClr val="0078D4"/>
+          </a:solidFill>
+          <a:ln>
+            <a:noFill/>
+          </a:ln>
+        </p:spPr>
+        <p:txBody>
+          <a:bodyPr vert="horz" lIns="91440" tIns="45720" rIns="91440" bIns="45720" anchor="ctr"/>
+          <a:lstStyle/>
+          <a:p>
+            <a:pPr algn="ctr"/>
+            <a:r>
+              <a:rPr lang="en-US" sz="933" b="1" dirty="0">
+                <a:solidFill>
+                  <a:srgbClr val="FFFFFF"/>
+                </a:solidFill>
+                <a:latin typeface="Calibri" pitchFamily="34" charset="0"/>
+              </a:rPr>
+              <a:t>Agent
+Middleware</a:t>
+            </a:r>
+          </a:p>
+        </p:txBody>
+      </p:sp>
+      <p:sp>
+        <p:nvSpPr>
+          <p:cNvPr id="121" name="Arrow0"/>
+          <p:cNvSpPr>
+            <a:spLocks noGrp="1"/>
+          </p:cNvSpPr>
+          <p:nvPr/>
+        </p:nvSpPr>
+        <p:spPr>
+          <a:xfrm>
+            <a:off x="2171700" y="3327400"/>
+            <a:ext cx="203200" cy="203200"/>
+          </a:xfrm>
+          <a:prstGeom prst="rightArrow">
+            <a:avLst/>
+          </a:prstGeom>
+          <a:solidFill>
+            <a:srgbClr val="4A5568"/>
+          </a:solidFill>
+          <a:ln>
+            <a:noFill/>
+          </a:ln>
+        </p:spPr>
+        <p:txBody>
+          <a:bodyPr/>
+          <a:lstStyle/>
+          <a:p>
+            <a:endParaRPr/>
+          </a:p>
+        </p:txBody>
+      </p:sp>
+      <p:sp>
+        <p:nvSpPr>
+          <p:cNvPr id="122" name="Flow1"/>
+          <p:cNvSpPr>
+            <a:spLocks noGrp="1"/>
+          </p:cNvSpPr>
+          <p:nvPr/>
+        </p:nvSpPr>
+        <p:spPr>
+          <a:xfrm>
+            <a:off x="2374900" y="3048000"/>
+            <a:ext cx="1625600" cy="762000"/>
+          </a:xfrm>
+          <a:prstGeom prst="rect">
+            <a:avLst/>
+          </a:prstGeom>
+          <a:solidFill>
+            <a:srgbClr val="0F1F3D"/>
+          </a:solidFill>
+          <a:ln>
+            <a:noFill/>
+          </a:ln>
+        </p:spPr>
+        <p:txBody>
+          <a:bodyPr vert="horz" lIns="91440" tIns="45720" rIns="91440" bIns="45720" anchor="ctr"/>
+          <a:lstStyle/>
+          <a:p>
+            <a:pPr algn="ctr"/>
+            <a:r>
+              <a:rPr lang="en-US" sz="933" b="1" dirty="0">
+                <a:solidFill>
+                  <a:srgbClr val="FFFFFF"/>
+                </a:solidFill>
+                <a:latin typeface="Calibri" pitchFamily="34" charset="0"/>
+              </a:rPr>
+              <a:t>Function
+Middleware</a:t>
+            </a:r>
+          </a:p>
+        </p:txBody>
+      </p:sp>
+      <p:sp>
+        <p:nvSpPr>
+          <p:cNvPr id="123" name="Arrow1"/>
+          <p:cNvSpPr>
+            <a:spLocks noGrp="1"/>
+          </p:cNvSpPr>
+          <p:nvPr/>
+        </p:nvSpPr>
+        <p:spPr>
+          <a:xfrm>
+            <a:off x="4000500" y="3327400"/>
+            <a:ext cx="203200" cy="203200"/>
+          </a:xfrm>
+          <a:prstGeom prst="rightArrow">
+            <a:avLst/>
+          </a:prstGeom>
+          <a:solidFill>
+            <a:srgbClr val="4A5568"/>
+          </a:solidFill>
+          <a:ln>
+            <a:noFill/>
+          </a:ln>
+        </p:spPr>
+        <p:txBody>
+          <a:bodyPr/>
+          <a:lstStyle/>
+          <a:p>
+            <a:endParaRPr/>
+          </a:p>
+        </p:txBody>
+      </p:sp>
+      <p:sp>
+        <p:nvSpPr>
+          <p:cNvPr id="124" name="Flow2"/>
+          <p:cNvSpPr>
+            <a:spLocks noGrp="1"/>
+          </p:cNvSpPr>
+          <p:nvPr/>
+        </p:nvSpPr>
+        <p:spPr>
+          <a:xfrm>
+            <a:off x="4203700" y="3048000"/>
+            <a:ext cx="1625600" cy="762000"/>
+          </a:xfrm>
+          <a:prstGeom prst="rect">
+            <a:avLst/>
+          </a:prstGeom>
+          <a:solidFill>
+            <a:srgbClr val="7B2FF7"/>
+          </a:solidFill>
+          <a:ln>
+            <a:noFill/>
+          </a:ln>
+        </p:spPr>
+        <p:txBody>
+          <a:bodyPr vert="horz" lIns="91440" tIns="45720" rIns="91440" bIns="45720" anchor="ctr"/>
+          <a:lstStyle/>
+          <a:p>
+            <a:pPr algn="ctr"/>
+            <a:r>
+              <a:rPr lang="en-US" sz="933" b="1" dirty="0">
+                <a:solidFill>
+                  <a:srgbClr val="FFFFFF"/>
+                </a:solidFill>
+                <a:latin typeface="Calibri" pitchFamily="34" charset="0"/>
+              </a:rPr>
+              <a:t>Chat
+Middleware</a:t>
+            </a:r>
+          </a:p>
+        </p:txBody>
+      </p:sp>
+      <p:sp>
+        <p:nvSpPr>
+          <p:cNvPr id="125" name="Arrow2"/>
+          <p:cNvSpPr>
+            <a:spLocks noGrp="1"/>
+          </p:cNvSpPr>
+          <p:nvPr/>
+        </p:nvSpPr>
+        <p:spPr>
+          <a:xfrm>
+            <a:off x="5829300" y="3327400"/>
+            <a:ext cx="203200" cy="203200"/>
+          </a:xfrm>
+          <a:prstGeom prst="rightArrow">
+            <a:avLst/>
+          </a:prstGeom>
+          <a:solidFill>
+            <a:srgbClr val="4A5568"/>
+          </a:solidFill>
+          <a:ln>
+            <a:noFill/>
+          </a:ln>
+        </p:spPr>
+        <p:txBody>
+          <a:bodyPr/>
+          <a:lstStyle/>
+          <a:p>
+            <a:endParaRPr/>
+          </a:p>
+        </p:txBody>
+      </p:sp>
+      <p:sp>
+        <p:nvSpPr>
+          <p:cNvPr id="126" name="Flow3"/>
+          <p:cNvSpPr>
+            <a:spLocks noGrp="1"/>
+          </p:cNvSpPr>
+          <p:nvPr/>
+        </p:nvSpPr>
+        <p:spPr>
+          <a:xfrm>
+            <a:off x="6032500" y="3048000"/>
+            <a:ext cx="1625600" cy="762000"/>
+          </a:xfrm>
+          <a:prstGeom prst="rect">
+            <a:avLst/>
+          </a:prstGeom>
+          <a:solidFill>
+            <a:srgbClr val="E65100"/>
+          </a:solidFill>
+          <a:ln>
+            <a:noFill/>
+          </a:ln>
+        </p:spPr>
+        <p:txBody>
+          <a:bodyPr vert="horz" lIns="91440" tIns="45720" rIns="91440" bIns="45720" anchor="ctr"/>
+          <a:lstStyle/>
+          <a:p>
+            <a:pPr algn="ctr"/>
+            <a:r>
+              <a:rPr lang="en-US" sz="933" b="1" dirty="0">
+                <a:solidFill>
+                  <a:srgbClr val="FFFFFF"/>
+                </a:solidFill>
+                <a:latin typeface="Calibri" pitchFamily="34" charset="0"/>
+              </a:rPr>
+              <a:t>LLM
+Call</a:t>
+            </a:r>
+          </a:p>
+        </p:txBody>
+      </p:sp>
+      <p:sp>
+        <p:nvSpPr>
+          <p:cNvPr id="127" name="Arrow3"/>
+          <p:cNvSpPr>
+            <a:spLocks noGrp="1"/>
+          </p:cNvSpPr>
+          <p:nvPr/>
+        </p:nvSpPr>
+        <p:spPr>
+          <a:xfrm>
+            <a:off x="7658100" y="3327400"/>
+            <a:ext cx="203200" cy="203200"/>
+          </a:xfrm>
+          <a:prstGeom prst="rightArrow">
+            <a:avLst/>
+          </a:prstGeom>
+          <a:solidFill>
+            <a:srgbClr val="4A5568"/>
+          </a:solidFill>
+          <a:ln>
+            <a:noFill/>
+          </a:ln>
+        </p:spPr>
+        <p:txBody>
+          <a:bodyPr/>
+          <a:lstStyle/>
+          <a:p>
+            <a:endParaRPr/>
+          </a:p>
+        </p:txBody>
+      </p:sp>
+      <p:sp>
+        <p:nvSpPr>
+          <p:cNvPr id="128" name="Flow4"/>
+          <p:cNvSpPr>
+            <a:spLocks noGrp="1"/>
+          </p:cNvSpPr>
+          <p:nvPr/>
+        </p:nvSpPr>
+        <p:spPr>
+          <a:xfrm>
+            <a:off x="7861300" y="3048000"/>
+            <a:ext cx="1625600" cy="762000"/>
+          </a:xfrm>
+          <a:prstGeom prst="rect">
+            <a:avLst/>
+          </a:prstGeom>
+          <a:solidFill>
+            <a:srgbClr val="2E7D32"/>
+          </a:solidFill>
+          <a:ln>
+            <a:noFill/>
+          </a:ln>
+        </p:spPr>
+        <p:txBody>
+          <a:bodyPr vert="horz" lIns="91440" tIns="45720" rIns="91440" bIns="45720" anchor="ctr"/>
+          <a:lstStyle/>
+          <a:p>
+            <a:pPr algn="ctr"/>
+            <a:r>
+              <a:rPr lang="en-US" sz="933" b="1" dirty="0">
+                <a:solidFill>
+                  <a:srgbClr val="FFFFFF"/>
+                </a:solidFill>
+                <a:latin typeface="Calibri" pitchFamily="34" charset="0"/>
+              </a:rPr>
+              <a:t>Response
+Returned</a:t>
+            </a:r>
+          </a:p>
+        </p:txBody>
+      </p:sp>
+      <p:sp>
+        <p:nvSpPr>
+          <p:cNvPr id="150" name="SkillBg"/>
+          <p:cNvSpPr>
+            <a:spLocks noGrp="1"/>
+          </p:cNvSpPr>
+          <p:nvPr/>
+        </p:nvSpPr>
+        <p:spPr>
+          <a:xfrm>
+            <a:off x="342900" y="4254500"/>
+            <a:ext cx="5588000" cy="1206500"/>
+          </a:xfrm>
+          <a:prstGeom prst="rect">
+            <a:avLst/>
+          </a:prstGeom>
+          <a:solidFill>
+            <a:srgbClr val="F0F5FA"/>
+          </a:solidFill>
+          <a:ln>
+            <a:noFill/>
+          </a:ln>
+        </p:spPr>
+        <p:txBody>
+          <a:bodyPr vert="horz" lIns="91440" tIns="45720" rIns="91440" bIns="45720" anchor="ctr"/>
+          <a:lstStyle/>
+          <a:p>
+            <a:endParaRPr lang="en-US" dirty="0"/>
+          </a:p>
+        </p:txBody>
+      </p:sp>
+      <p:sp>
+        <p:nvSpPr>
+          <p:cNvPr id="151" name="SkillAccent"/>
+          <p:cNvSpPr>
+            <a:spLocks noGrp="1"/>
+          </p:cNvSpPr>
+          <p:nvPr/>
+        </p:nvSpPr>
+        <p:spPr>
+          <a:xfrm>
+            <a:off x="393700" y="4254500"/>
+            <a:ext cx="5486400" cy="63500"/>
+          </a:xfrm>
+          <a:prstGeom prst="rect">
+            <a:avLst/>
+          </a:prstGeom>
+          <a:solidFill>
+            <a:srgbClr val="00B4D8"/>
+          </a:solidFill>
+          <a:ln>
+            <a:noFill/>
+          </a:ln>
+        </p:spPr>
+        <p:txBody>
+          <a:bodyPr vert="horz" lIns="91440" tIns="45720" rIns="91440" bIns="45720" anchor="ctr"/>
+          <a:lstStyle/>
+          <a:p>
+            <a:endParaRPr lang="en-US" dirty="0"/>
+          </a:p>
+        </p:txBody>
+      </p:sp>
+      <p:sp>
+        <p:nvSpPr>
+          <p:cNvPr id="152" name="SkillTitle"/>
+          <p:cNvSpPr>
+            <a:spLocks noGrp="1"/>
+          </p:cNvSpPr>
+          <p:nvPr/>
+        </p:nvSpPr>
+        <p:spPr>
+          <a:xfrm>
+            <a:off x="508000" y="4406900"/>
+            <a:ext cx="5245100" cy="254000"/>
+          </a:xfrm>
+          <a:prstGeom prst="rect">
+            <a:avLst/>
+          </a:prstGeom>
+          <a:noFill/>
+          <a:ln>
+            <a:noFill/>
+          </a:ln>
+        </p:spPr>
+        <p:txBody>
+          <a:bodyPr vert="horz" lIns="91440" tIns="45720" rIns="91440" bIns="45720" anchor="ctr"/>
+          <a:lstStyle/>
+          <a:p>
+            <a:r>
+              <a:rPr lang="en-US" sz="1467" b="1" dirty="0">
+                <a:solidFill>
+                  <a:srgbClr val="0F1F3D"/>
+                </a:solidFill>
+                <a:latin typeface="Calibri" pitchFamily="34" charset="0"/>
+              </a:rPr>
+              <a:t>Agent Run Middleware</a:t>
+            </a:r>
+          </a:p>
+        </p:txBody>
+      </p:sp>
+      <p:sp>
+        <p:nvSpPr>
+          <p:cNvPr id="153" name="SkillContent"/>
+          <p:cNvSpPr>
+            <a:spLocks noGrp="1"/>
+          </p:cNvSpPr>
+          <p:nvPr/>
+        </p:nvSpPr>
+        <p:spPr>
+          <a:xfrm>
+            <a:off x="508000" y="4711700"/>
+            <a:ext cx="5245100" cy="673100"/>
+          </a:xfrm>
+          <a:prstGeom prst="rect">
+            <a:avLst/>
+          </a:prstGeom>
+          <a:noFill/>
+          <a:ln>
+            <a:noFill/>
+          </a:ln>
+        </p:spPr>
+        <p:txBody>
+          <a:bodyPr vert="horz" lIns="91440" tIns="45720" rIns="91440" bIns="45720" anchor="ctr"/>
+          <a:lstStyle/>
+          <a:p>
+            <a:pPr marL="152396" indent="-152396">
+              <a:spcBef>
+                <a:spcPts val="200"/>
+              </a:spcBef>
+              <a:buFont typeface="Arial"/>
+              <a:buChar char="•"/>
+            </a:pPr>
+            <a:r>
+              <a:rPr lang="en-US" sz="1067" dirty="0">
+                <a:solidFill>
+                  <a:srgbClr val="4A5568"/>
+                </a:solidFill>
+                <a:latin typeface="Calibri" pitchFamily="34" charset="0"/>
+              </a:rPr>
+              <a:t>Outermost layer — fires once per agent turn</a:t>
+            </a:r>
+          </a:p>
+          <a:p>
+            <a:pPr marL="152396" indent="-152396">
+              <a:spcBef>
+                <a:spcPts val="200"/>
+              </a:spcBef>
+              <a:buFont typeface="Arial"/>
+              <a:buChar char="•"/>
+            </a:pPr>
+            <a:r>
+              <a:rPr lang="en-US" sz="1067" dirty="0">
+                <a:solidFill>
+                  <a:srgbClr val="4A5568"/>
+                </a:solidFill>
+                <a:latin typeface="Calibri" pitchFamily="34" charset="0"/>
+              </a:rPr>
+              <a:t>Wraps entire run: inspect inputs &amp; outputs end-to-end</a:t>
+            </a:r>
+          </a:p>
+          <a:p>
+            <a:pPr marL="152396" indent="-152396">
+              <a:spcBef>
+                <a:spcPts val="200"/>
+              </a:spcBef>
+              <a:buFont typeface="Arial"/>
+              <a:buChar char="•"/>
+            </a:pPr>
+            <a:r>
+              <a:rPr lang="en-US" sz="1067" dirty="0">
+                <a:solidFill>
+                  <a:srgbClr val="4A5568"/>
+                </a:solidFill>
+                <a:latin typeface="Calibri" pitchFamily="34" charset="0"/>
+              </a:rPr>
+              <a:t>Implement via .Use() delegate or IAgentMiddleware class</a:t>
+            </a:r>
+          </a:p>
+        </p:txBody>
+      </p:sp>
+      <p:sp>
+        <p:nvSpPr>
+          <p:cNvPr id="160" name="WireBg"/>
+          <p:cNvSpPr>
+            <a:spLocks noGrp="1"/>
+          </p:cNvSpPr>
+          <p:nvPr/>
+        </p:nvSpPr>
+        <p:spPr>
+          <a:xfrm>
+            <a:off x="6261100" y="4254500"/>
+            <a:ext cx="5588000" cy="1206500"/>
+          </a:xfrm>
+          <a:prstGeom prst="rect">
+            <a:avLst/>
+          </a:prstGeom>
+          <a:solidFill>
+            <a:srgbClr val="F0F5FA"/>
+          </a:solidFill>
+          <a:ln>
+            <a:noFill/>
+          </a:ln>
+        </p:spPr>
+        <p:txBody>
+          <a:bodyPr vert="horz" lIns="91440" tIns="45720" rIns="91440" bIns="45720" anchor="ctr"/>
+          <a:lstStyle/>
+          <a:p>
+            <a:endParaRPr lang="en-US" dirty="0"/>
+          </a:p>
+        </p:txBody>
+      </p:sp>
+      <p:sp>
+        <p:nvSpPr>
+          <p:cNvPr id="161" name="WireAccent"/>
+          <p:cNvSpPr>
+            <a:spLocks noGrp="1"/>
+          </p:cNvSpPr>
+          <p:nvPr/>
+        </p:nvSpPr>
+        <p:spPr>
+          <a:xfrm>
+            <a:off x="6311900" y="4254500"/>
+            <a:ext cx="5486400" cy="63500"/>
+          </a:xfrm>
+          <a:prstGeom prst="rect">
+            <a:avLst/>
+          </a:prstGeom>
+          <a:solidFill>
+            <a:srgbClr val="7B2FF7"/>
+          </a:solidFill>
+          <a:ln>
+            <a:noFill/>
+          </a:ln>
+        </p:spPr>
+        <p:txBody>
+          <a:bodyPr vert="horz" lIns="91440" tIns="45720" rIns="91440" bIns="45720" anchor="ctr"/>
+          <a:lstStyle/>
+          <a:p>
+            <a:endParaRPr lang="en-US" dirty="0"/>
+          </a:p>
+        </p:txBody>
+      </p:sp>
+      <p:sp>
+        <p:nvSpPr>
+          <p:cNvPr id="162" name="WireTitle"/>
+          <p:cNvSpPr>
+            <a:spLocks noGrp="1"/>
+          </p:cNvSpPr>
+          <p:nvPr/>
+        </p:nvSpPr>
+        <p:spPr>
+          <a:xfrm>
+            <a:off x="6438900" y="4406900"/>
+            <a:ext cx="5245100" cy="254000"/>
+          </a:xfrm>
+          <a:prstGeom prst="rect">
+            <a:avLst/>
+          </a:prstGeom>
+          <a:noFill/>
+          <a:ln>
+            <a:noFill/>
+          </a:ln>
+        </p:spPr>
+        <p:txBody>
+          <a:bodyPr vert="horz" lIns="91440" tIns="45720" rIns="91440" bIns="45720" anchor="ctr"/>
+          <a:lstStyle/>
+          <a:p>
+            <a:r>
+              <a:rPr lang="en-US" sz="1467" b="1" dirty="0">
+                <a:solidFill>
+                  <a:srgbClr val="0F1F3D"/>
+                </a:solidFill>
+                <a:latin typeface="Calibri" pitchFamily="34" charset="0"/>
+              </a:rPr>
+              <a:t>Function &amp; Chat Middleware</a:t>
+            </a:r>
+          </a:p>
+        </p:txBody>
+      </p:sp>
+      <p:sp>
+        <p:nvSpPr>
+          <p:cNvPr id="163" name="WireContent"/>
+          <p:cNvSpPr>
+            <a:spLocks noGrp="1"/>
+          </p:cNvSpPr>
+          <p:nvPr/>
+        </p:nvSpPr>
+        <p:spPr>
+          <a:xfrm>
+            <a:off x="6438900" y="4711700"/>
+            <a:ext cx="5245100" cy="673100"/>
+          </a:xfrm>
+          <a:prstGeom prst="rect">
+            <a:avLst/>
+          </a:prstGeom>
+          <a:noFill/>
+          <a:ln>
+            <a:noFill/>
+          </a:ln>
+        </p:spPr>
+        <p:txBody>
+          <a:bodyPr vert="horz" lIns="91440" tIns="45720" rIns="91440" bIns="45720" anchor="ctr"/>
+          <a:lstStyle/>
+          <a:p>
+            <a:pPr marL="152396" indent="-152396">
+              <a:spcBef>
+                <a:spcPts val="200"/>
+              </a:spcBef>
+              <a:buFont typeface="Arial"/>
+              <a:buChar char="•"/>
+            </a:pPr>
+            <a:r>
+              <a:rPr lang="en-US" sz="1067" dirty="0">
+                <a:solidFill>
+                  <a:srgbClr val="4A5568"/>
+                </a:solidFill>
+                <a:latin typeface="Calibri" pitchFamily="34" charset="0"/>
+              </a:rPr>
+              <a:t>Function MW: intercepts every tool call — validate, transform, block</a:t>
+            </a:r>
+          </a:p>
+          <a:p>
+            <a:pPr marL="152396" indent="-152396">
+              <a:spcBef>
+                <a:spcPts val="200"/>
+              </a:spcBef>
+              <a:buFont typeface="Arial"/>
+              <a:buChar char="•"/>
+            </a:pPr>
+            <a:r>
+              <a:rPr lang="en-US" sz="1067" dirty="0">
+                <a:solidFill>
+                  <a:srgbClr val="4A5568"/>
+                </a:solidFill>
+                <a:latin typeface="Calibri" pitchFamily="34" charset="0"/>
+              </a:rPr>
+              <a:t>Chat MW: intercepts raw LLM requests — inspect messages &amp; responses</a:t>
+            </a:r>
+          </a:p>
+          <a:p>
+            <a:pPr marL="152396" indent="-152396">
+              <a:spcBef>
+                <a:spcPts val="200"/>
+              </a:spcBef>
+              <a:buFont typeface="Arial"/>
+              <a:buChar char="•"/>
+            </a:pPr>
+            <a:r>
+              <a:rPr lang="en-US" sz="1067" dirty="0">
+                <a:solidFill>
+                  <a:srgbClr val="4A5568"/>
+                </a:solidFill>
+                <a:latin typeface="Calibri" pitchFamily="34" charset="0"/>
+              </a:rPr>
+              <a:t>All types support function-based and class-based (.NET) styles</a:t>
+            </a:r>
+          </a:p>
+        </p:txBody>
+      </p:sp>
+      <p:sp>
+        <p:nvSpPr>
+          <p:cNvPr id="170" name="ConsBg"/>
+          <p:cNvSpPr>
+            <a:spLocks noGrp="1"/>
+          </p:cNvSpPr>
+          <p:nvPr/>
+        </p:nvSpPr>
+        <p:spPr>
+          <a:xfrm>
+            <a:off x="342900" y="5588000"/>
+            <a:ext cx="11518900" cy="279400"/>
+          </a:xfrm>
+          <a:prstGeom prst="rect">
+            <a:avLst/>
+          </a:prstGeom>
+          <a:solidFill>
+            <a:srgbClr val="FFF3E0"/>
+          </a:solidFill>
+          <a:ln>
+            <a:noFill/>
+          </a:ln>
+        </p:spPr>
+        <p:txBody>
+          <a:bodyPr vert="horz" lIns="91440" tIns="45720" rIns="91440" bIns="45720" anchor="ctr"/>
+          <a:lstStyle/>
+          <a:p>
+            <a:endParaRPr lang="en-US" dirty="0"/>
+          </a:p>
+        </p:txBody>
+      </p:sp>
+      <p:sp>
+        <p:nvSpPr>
+          <p:cNvPr id="171" name="ConsAccent"/>
+          <p:cNvSpPr>
+            <a:spLocks noGrp="1"/>
+          </p:cNvSpPr>
+          <p:nvPr/>
+        </p:nvSpPr>
+        <p:spPr>
+          <a:xfrm>
+            <a:off x="342900" y="5588000"/>
+            <a:ext cx="88900" cy="279400"/>
+          </a:xfrm>
+          <a:prstGeom prst="rect">
+            <a:avLst/>
+          </a:prstGeom>
+          <a:solidFill>
+            <a:srgbClr val="E65100"/>
+          </a:solidFill>
+          <a:ln>
+            <a:noFill/>
+          </a:ln>
+        </p:spPr>
+        <p:txBody>
+          <a:bodyPr vert="horz" lIns="91440" tIns="45720" rIns="91440" bIns="45720" anchor="ctr"/>
+          <a:lstStyle/>
+          <a:p>
+            <a:endParaRPr lang="en-US" dirty="0"/>
+          </a:p>
+        </p:txBody>
+      </p:sp>
+      <p:sp>
+        <p:nvSpPr>
+          <p:cNvPr id="172" name="ConsTitle"/>
+          <p:cNvSpPr>
+            <a:spLocks noGrp="1"/>
+          </p:cNvSpPr>
+          <p:nvPr/>
+        </p:nvSpPr>
+        <p:spPr>
+          <a:xfrm>
+            <a:off x="546100" y="5600700"/>
+            <a:ext cx="3810000" cy="254000"/>
+          </a:xfrm>
+          <a:prstGeom prst="rect">
+            <a:avLst/>
+          </a:prstGeom>
+          <a:noFill/>
+          <a:ln>
+            <a:noFill/>
+          </a:ln>
+        </p:spPr>
+        <p:txBody>
+          <a:bodyPr vert="horz" lIns="91440" tIns="45720" rIns="91440" bIns="45720" anchor="ctr"/>
+          <a:lstStyle/>
+          <a:p>
+            <a:r>
+              <a:rPr lang="en-US" sz="1467" b="1" dirty="0">
+                <a:solidFill>
+                  <a:srgbClr val="E65100"/>
+                </a:solidFill>
+                <a:latin typeface="Calibri" pitchFamily="34" charset="0"/>
+              </a:rPr>
+              <a:t>Key Considerations</a:t>
+            </a:r>
+          </a:p>
+        </p:txBody>
+      </p:sp>
+      <p:sp>
+        <p:nvSpPr>
+          <p:cNvPr id="180" name="Pill0"/>
+          <p:cNvSpPr>
+            <a:spLocks noGrp="1"/>
+          </p:cNvSpPr>
+          <p:nvPr/>
+        </p:nvSpPr>
+        <p:spPr>
+          <a:xfrm>
+            <a:off x="368300" y="5918200"/>
+            <a:ext cx="2755900" cy="482600"/>
+          </a:xfrm>
+          <a:prstGeom prst="roundRect">
+            <a:avLst>
+              <a:gd name="adj" fmla="val 16667"/>
+            </a:avLst>
+          </a:prstGeom>
+          <a:solidFill>
+            <a:srgbClr val="F0F5FA"/>
+          </a:solidFill>
+          <a:ln>
+            <a:noFill/>
+          </a:ln>
+        </p:spPr>
+        <p:txBody>
+          <a:bodyPr vert="horz" lIns="91440" tIns="45720" rIns="91440" bIns="45720" anchor="ctr"/>
+          <a:lstStyle/>
+          <a:p>
+            <a:endParaRPr lang="en-US" dirty="0"/>
+          </a:p>
+        </p:txBody>
+      </p:sp>
+      <p:sp>
+        <p:nvSpPr>
+          <p:cNvPr id="181" name="PillT0"/>
+          <p:cNvSpPr>
+            <a:spLocks noGrp="1"/>
+          </p:cNvSpPr>
+          <p:nvPr/>
+        </p:nvSpPr>
+        <p:spPr>
+          <a:xfrm>
+            <a:off x="444500" y="5930900"/>
+            <a:ext cx="2603500" cy="457200"/>
+          </a:xfrm>
+          <a:prstGeom prst="rect">
+            <a:avLst/>
+          </a:prstGeom>
+          <a:noFill/>
+          <a:ln>
+            <a:noFill/>
+          </a:ln>
+        </p:spPr>
+        <p:txBody>
+          <a:bodyPr vert="horz" lIns="91440" tIns="45720" rIns="91440" bIns="45720" anchor="ctr"/>
+          <a:lstStyle/>
+          <a:p>
+            <a:r>
+              <a:rPr lang="en-US" sz="1067" b="1" dirty="0">
+                <a:solidFill>
+                  <a:srgbClr val="E65100"/>
+                </a:solidFill>
+                <a:latin typeface="Calibri" pitchFamily="34" charset="0"/>
+              </a:rPr>
+              <a:t>🔗 Chain Order</a:t>
+            </a:r>
+          </a:p>
+          <a:p>
+            <a:pPr>
+              <a:spcBef>
+                <a:spcPts val="50"/>
+              </a:spcBef>
+            </a:pPr>
+            <a:r>
+              <a:rPr lang="en-US" sz="867" dirty="0">
+                <a:solidFill>
+                  <a:srgbClr val="4A5568"/>
+                </a:solidFill>
+                <a:latin typeface="Calibri" pitchFamily="34" charset="0"/>
+              </a:rPr>
+              <a:t>Registered order = execution order in chain</a:t>
+            </a:r>
+          </a:p>
+        </p:txBody>
+      </p:sp>
+      <p:sp>
+        <p:nvSpPr>
+          <p:cNvPr id="182" name="Pill1"/>
+          <p:cNvSpPr>
+            <a:spLocks noGrp="1"/>
+          </p:cNvSpPr>
+          <p:nvPr/>
+        </p:nvSpPr>
+        <p:spPr>
+          <a:xfrm>
+            <a:off x="3200400" y="5918200"/>
+            <a:ext cx="2755900" cy="482600"/>
+          </a:xfrm>
+          <a:prstGeom prst="roundRect">
+            <a:avLst>
+              <a:gd name="adj" fmla="val 16667"/>
+            </a:avLst>
+          </a:prstGeom>
+          <a:solidFill>
+            <a:srgbClr val="F0F5FA"/>
+          </a:solidFill>
+          <a:ln>
+            <a:noFill/>
+          </a:ln>
+        </p:spPr>
+        <p:txBody>
+          <a:bodyPr vert="horz" lIns="91440" tIns="45720" rIns="91440" bIns="45720" anchor="ctr"/>
+          <a:lstStyle/>
+          <a:p>
+            <a:endParaRPr lang="en-US" dirty="0"/>
+          </a:p>
+        </p:txBody>
+      </p:sp>
+      <p:sp>
+        <p:nvSpPr>
+          <p:cNvPr id="183" name="PillT1"/>
+          <p:cNvSpPr>
+            <a:spLocks noGrp="1"/>
+          </p:cNvSpPr>
+          <p:nvPr/>
+        </p:nvSpPr>
+        <p:spPr>
+          <a:xfrm>
+            <a:off x="3276600" y="5930900"/>
+            <a:ext cx="2603500" cy="457200"/>
+          </a:xfrm>
+          <a:prstGeom prst="rect">
+            <a:avLst/>
+          </a:prstGeom>
+          <a:noFill/>
+          <a:ln>
+            <a:noFill/>
+          </a:ln>
+        </p:spPr>
+        <p:txBody>
+          <a:bodyPr vert="horz" lIns="91440" tIns="45720" rIns="91440" bIns="45720" anchor="ctr"/>
+          <a:lstStyle/>
+          <a:p>
+            <a:r>
+              <a:rPr lang="en-US" sz="1067" b="1" dirty="0">
+                <a:solidFill>
+                  <a:srgbClr val="0078D4"/>
+                </a:solidFill>
+                <a:latin typeface="Calibri" pitchFamily="34" charset="0"/>
+              </a:rPr>
+              <a:t>⛔ Early Termination</a:t>
+            </a:r>
+          </a:p>
+          <a:p>
+            <a:pPr>
+              <a:spcBef>
+                <a:spcPts val="50"/>
+              </a:spcBef>
+            </a:pPr>
+            <a:r>
+              <a:rPr lang="en-US" sz="867" dirty="0">
+                <a:solidFill>
+                  <a:srgbClr val="4A5568"/>
+                </a:solidFill>
+                <a:latin typeface="Calibri" pitchFamily="34" charset="0"/>
+              </a:rPr>
+              <a:t>Skip call_next() to short-circuit pipeline</a:t>
+            </a:r>
+          </a:p>
+        </p:txBody>
+      </p:sp>
+      <p:sp>
+        <p:nvSpPr>
+          <p:cNvPr id="184" name="Pill2"/>
+          <p:cNvSpPr>
+            <a:spLocks noGrp="1"/>
+          </p:cNvSpPr>
+          <p:nvPr/>
+        </p:nvSpPr>
+        <p:spPr>
+          <a:xfrm>
+            <a:off x="6032500" y="5918200"/>
+            <a:ext cx="2755900" cy="482600"/>
+          </a:xfrm>
+          <a:prstGeom prst="roundRect">
+            <a:avLst>
+              <a:gd name="adj" fmla="val 16667"/>
+            </a:avLst>
+          </a:prstGeom>
+          <a:solidFill>
+            <a:srgbClr val="F0F5FA"/>
+          </a:solidFill>
+          <a:ln>
+            <a:noFill/>
+          </a:ln>
+        </p:spPr>
+        <p:txBody>
+          <a:bodyPr vert="horz" lIns="91440" tIns="45720" rIns="91440" bIns="45720" anchor="ctr"/>
+          <a:lstStyle/>
+          <a:p>
+            <a:endParaRPr lang="en-US" dirty="0"/>
+          </a:p>
+        </p:txBody>
+      </p:sp>
+      <p:sp>
+        <p:nvSpPr>
+          <p:cNvPr id="185" name="PillT2"/>
+          <p:cNvSpPr>
+            <a:spLocks noGrp="1"/>
+          </p:cNvSpPr>
+          <p:nvPr/>
+        </p:nvSpPr>
+        <p:spPr>
+          <a:xfrm>
+            <a:off x="6108700" y="5930900"/>
+            <a:ext cx="2603500" cy="457200"/>
+          </a:xfrm>
+          <a:prstGeom prst="rect">
+            <a:avLst/>
+          </a:prstGeom>
+          <a:noFill/>
+          <a:ln>
+            <a:noFill/>
+          </a:ln>
+        </p:spPr>
+        <p:txBody>
+          <a:bodyPr vert="horz" lIns="91440" tIns="45720" rIns="91440" bIns="45720" anchor="ctr"/>
+          <a:lstStyle/>
+          <a:p>
+            <a:r>
+              <a:rPr lang="en-US" sz="1067" b="1" dirty="0">
+                <a:solidFill>
+                  <a:srgbClr val="7B2FF7"/>
+                </a:solidFill>
+                <a:latin typeface="Calibri" pitchFamily="34" charset="0"/>
+              </a:rPr>
+              <a:t>🔒 Security</a:t>
+            </a:r>
+          </a:p>
+          <a:p>
+            <a:pPr>
+              <a:spcBef>
+                <a:spcPts val="50"/>
+              </a:spcBef>
+            </a:pPr>
+            <a:r>
+              <a:rPr lang="en-US" sz="867" dirty="0">
+                <a:solidFill>
+                  <a:srgbClr val="4A5568"/>
+                </a:solidFill>
+                <a:latin typeface="Calibri" pitchFamily="34" charset="0"/>
+              </a:rPr>
+              <a:t>Block sensitive inputs before they reach the LLM</a:t>
+            </a:r>
+          </a:p>
+        </p:txBody>
+      </p:sp>
+      <p:sp>
+        <p:nvSpPr>
+          <p:cNvPr id="186" name="Pill3"/>
+          <p:cNvSpPr>
+            <a:spLocks noGrp="1"/>
+          </p:cNvSpPr>
+          <p:nvPr/>
+        </p:nvSpPr>
+        <p:spPr>
+          <a:xfrm>
+            <a:off x="8864600" y="5918200"/>
+            <a:ext cx="2755900" cy="482600"/>
+          </a:xfrm>
+          <a:prstGeom prst="roundRect">
+            <a:avLst>
+              <a:gd name="adj" fmla="val 16667"/>
+            </a:avLst>
+          </a:prstGeom>
+          <a:solidFill>
+            <a:srgbClr val="F0F5FA"/>
+          </a:solidFill>
+          <a:ln>
+            <a:noFill/>
+          </a:ln>
+        </p:spPr>
+        <p:txBody>
+          <a:bodyPr vert="horz" lIns="91440" tIns="45720" rIns="91440" bIns="45720" anchor="ctr"/>
+          <a:lstStyle/>
+          <a:p>
+            <a:endParaRPr lang="en-US" dirty="0"/>
+          </a:p>
+        </p:txBody>
+      </p:sp>
+      <p:sp>
+        <p:nvSpPr>
+          <p:cNvPr id="187" name="PillT3"/>
+          <p:cNvSpPr>
+            <a:spLocks noGrp="1"/>
+          </p:cNvSpPr>
+          <p:nvPr/>
+        </p:nvSpPr>
+        <p:spPr>
+          <a:xfrm>
+            <a:off x="8940800" y="5930900"/>
+            <a:ext cx="2603500" cy="457200"/>
+          </a:xfrm>
+          <a:prstGeom prst="rect">
+            <a:avLst/>
+          </a:prstGeom>
+          <a:noFill/>
+          <a:ln>
+            <a:noFill/>
+          </a:ln>
+        </p:spPr>
+        <p:txBody>
+          <a:bodyPr vert="horz" lIns="91440" tIns="45720" rIns="91440" bIns="45720" anchor="ctr"/>
+          <a:lstStyle/>
+          <a:p>
+            <a:r>
+              <a:rPr lang="en-US" sz="1067" b="1" dirty="0">
+                <a:solidFill>
+                  <a:srgbClr val="2E7D32"/>
+                </a:solidFill>
+                <a:latin typeface="Calibri" pitchFamily="34" charset="0"/>
+              </a:rPr>
+              <a:t>🧩 Composability</a:t>
+            </a:r>
+          </a:p>
+          <a:p>
+            <a:pPr>
+              <a:spcBef>
+                <a:spcPts val="50"/>
+              </a:spcBef>
+            </a:pPr>
+            <a:r>
+              <a:rPr lang="en-US" sz="867" dirty="0">
+                <a:solidFill>
+                  <a:srgbClr val="4A5568"/>
+                </a:solidFill>
+                <a:latin typeface="Calibri" pitchFamily="34" charset="0"/>
+              </a:rPr>
+              <a:t>Stack multiple middleware via builder pattern</a:t>
+            </a:r>
+          </a:p>
+        </p:txBody>
+      </p:sp>
+      <p:sp>
+        <p:nvSpPr>
+          <p:cNvPr id="190" name="FooterBg"/>
+          <p:cNvSpPr>
+            <a:spLocks noGrp="1"/>
+          </p:cNvSpPr>
+          <p:nvPr/>
+        </p:nvSpPr>
+        <p:spPr>
+          <a:xfrm>
+            <a:off x="0" y="6388100"/>
+            <a:ext cx="12192000" cy="469900"/>
+          </a:xfrm>
+          <a:prstGeom prst="rect">
+            <a:avLst/>
+          </a:prstGeom>
+          <a:solidFill>
+            <a:srgbClr val="0F1F3D"/>
+          </a:solidFill>
+          <a:ln>
+            <a:noFill/>
+          </a:ln>
+        </p:spPr>
+        <p:txBody>
+          <a:bodyPr vert="horz" lIns="91440" tIns="45720" rIns="91440" bIns="45720" anchor="ctr"/>
+          <a:lstStyle/>
+          <a:p>
+            <a:endParaRPr lang="en-US" dirty="0"/>
+          </a:p>
+        </p:txBody>
+      </p:sp>
+      <p:sp>
+        <p:nvSpPr>
+          <p:cNvPr id="2" name="Text 27">
+            <a:extLst>
+              <a:ext uri="{FF2B5EF4-FFF2-40B4-BE49-F238E27FC236}">
+                <a16:creationId xmlns:a16="http://schemas.microsoft.com/office/drawing/2014/main" id="{A4116B28-01F2-D2C0-0845-0341796C00C6}"/>
+              </a:ext>
+            </a:extLst>
+          </p:cNvPr>
+          <p:cNvSpPr/>
+          <p:nvPr/>
+        </p:nvSpPr>
+        <p:spPr>
+          <a:xfrm>
+            <a:off x="365760" y="6425184"/>
+            <a:ext cx="11460480" cy="365760"/>
+          </a:xfrm>
+          <a:prstGeom prst="rect">
+            <a:avLst/>
+          </a:prstGeom>
+          <a:noFill/>
+          <a:ln/>
+        </p:spPr>
+        <p:txBody>
+          <a:bodyPr wrap="square" lIns="0" tIns="0" rIns="0" bIns="0" rtlCol="0" anchor="ctr"/>
+          <a:lstStyle/>
+          <a:p>
+            <a:pPr defTabSz="1219170"/>
+            <a:r>
+              <a:rPr lang="en-US" sz="1200" dirty="0">
+                <a:solidFill>
+                  <a:srgbClr val="6A9CC7"/>
+                </a:solidFill>
+                <a:latin typeface="Calibri" pitchFamily="34" charset="0"/>
+              </a:rPr>
+              <a:t>Microsoft Agent Framework  ·  learn.microsoft.com/en-us/agent-framework/agents/middleware</a:t>
+            </a:r>
+          </a:p>
+        </p:txBody>
+      </p:sp>
+      <p:sp>
+        <p:nvSpPr>
+          <p:cNvPr id="3" name="WhyDivider">
+            <a:extLst>
+              <a:ext uri="{FF2B5EF4-FFF2-40B4-BE49-F238E27FC236}">
+                <a16:creationId xmlns:a16="http://schemas.microsoft.com/office/drawing/2014/main" id="{56FFB75E-1855-4B7A-9EF3-241B8A3D9789}"/>
+              </a:ext>
+            </a:extLst>
+          </p:cNvPr>
+          <p:cNvSpPr/>
+          <p:nvPr/>
+        </p:nvSpPr>
+        <p:spPr>
+          <a:xfrm>
+            <a:off x="5994400" y="1384300"/>
+            <a:ext cx="25400" cy="1066800"/>
+          </a:xfrm>
+          <a:prstGeom prst="rect">
+            <a:avLst/>
+          </a:prstGeom>
+          <a:solidFill>
+            <a:srgbClr val="D0D8E4"/>
+          </a:solidFill>
+          <a:ln w="19050" cap="flat" cmpd="sng" algn="ctr">
+            <a:noFill/>
+            <a:prstDash val="solid"/>
+            <a:miter lim="800000"/>
+          </a:ln>
+        </p:spPr>
+        <p:style>
+          <a:lnRef idx="2">
+            <a:schemeClr val="accent1">
+              <a:shade val="15000"/>
+            </a:schemeClr>
+          </a:lnRef>
+          <a:fillRef idx="1">
+            <a:schemeClr val="accent1"/>
+          </a:fillRef>
+          <a:effectRef idx="0">
+            <a:schemeClr val="accent1"/>
+          </a:effectRef>
+          <a:fontRef idx="minor">
+            <a:schemeClr val="lt1"/>
+          </a:fontRef>
+        </p:style>
+        <p:txBody>
+          <a:bodyPr vertOverflow="clip" horzOverflow="clip" rtlCol="0" anchor="t"/>
+          <a:lstStyle/>
+          <a:p>
+            <a:pPr algn="l"/>
+            <a:endParaRPr lang="en-IN"/>
+          </a:p>
+        </p:txBody>
+      </p:sp>
+      <p:sp>
+        <p:nvSpPr>
+          <p:cNvPr id="4" name="WhyAgentSkills">
+            <a:extLst>
+              <a:ext uri="{FF2B5EF4-FFF2-40B4-BE49-F238E27FC236}">
+                <a16:creationId xmlns:a16="http://schemas.microsoft.com/office/drawing/2014/main" id="{3FFF722E-3781-406F-A376-AE2FECF9AD43}"/>
+              </a:ext>
+            </a:extLst>
+          </p:cNvPr>
+          <p:cNvSpPr txBox="1"/>
+          <p:nvPr/>
+        </p:nvSpPr>
+        <p:spPr>
+          <a:xfrm>
+            <a:off x="6121400" y="1384300"/>
+            <a:ext cx="5270500" cy="1066800"/>
+          </a:xfrm>
+          <a:prstGeom prst="rect">
+            <a:avLst/>
+          </a:prstGeom>
+          <a:noFill/>
+        </p:spPr>
+        <p:txBody>
+          <a:bodyPr vertOverflow="overflow" vert="horz" wrap="square" rtlCol="0" anchor="t">
+            <a:noAutofit/>
+          </a:bodyPr>
+          <a:lstStyle/>
+          <a:p>
+            <a:pPr>
+              <a:spcBef>
+                <a:spcPts val="0"/>
+              </a:spcBef>
+              <a:buNone/>
+            </a:pPr>
+            <a:r>
+              <a:rPr lang="en-US" sz="1200" b="1" dirty="0">
+                <a:solidFill>
+                  <a:srgbClr val="0078D4"/>
+                </a:solidFill>
+                <a:latin typeface="Calibri" pitchFamily="34" charset="0"/>
+              </a:rPr>
+              <a:t>Why Middleware?</a:t>
+            </a:r>
+          </a:p>
+          <a:p>
+            <a:pPr marL="114300" indent="-114300">
+              <a:spcBef>
+                <a:spcPts val="150"/>
+              </a:spcBef>
+              <a:buFont typeface="Arial"/>
+              <a:buChar char="•"/>
+            </a:pPr>
+            <a:r>
+              <a:rPr lang="en-US" sz="1000" dirty="0">
+                <a:solidFill>
+                  <a:srgbClr val="4A5568"/>
+                </a:solidFill>
+                <a:latin typeface="Calibri" pitchFamily="34" charset="0"/>
+              </a:rPr>
+              <a:t>Logging &amp; observability: trace every turn and tool call</a:t>
+            </a:r>
+          </a:p>
+          <a:p>
+            <a:pPr marL="114300" indent="-114300">
+              <a:spcBef>
+                <a:spcPts val="150"/>
+              </a:spcBef>
+              <a:buFont typeface="Arial"/>
+              <a:buChar char="•"/>
+            </a:pPr>
+            <a:r>
+              <a:rPr lang="en-US" sz="1000" dirty="0">
+                <a:solidFill>
+                  <a:srgbClr val="4A5568"/>
+                </a:solidFill>
+                <a:latin typeface="Calibri" pitchFamily="34" charset="0"/>
+              </a:rPr>
+              <a:t>Security validation: block or transform inputs before they reach the agent</a:t>
+            </a:r>
+          </a:p>
+          <a:p>
+            <a:pPr marL="114300" indent="-114300">
+              <a:spcBef>
+                <a:spcPts val="150"/>
+              </a:spcBef>
+              <a:buFont typeface="Arial"/>
+              <a:buChar char="•"/>
+            </a:pPr>
+            <a:r>
+              <a:rPr lang="en-US" sz="1000" dirty="0">
+                <a:solidFill>
+                  <a:srgbClr val="4A5568"/>
+                </a:solidFill>
+                <a:latin typeface="Calibri" pitchFamily="34" charset="0"/>
+              </a:rPr>
+              <a:t>Error handling &amp; rate limiting: control flow without changing business logic</a:t>
+            </a:r>
+          </a:p>
+        </p:txBody>
+      </p:sp>
+    </p:spTree>
+    <p:extLst>
+      <p:ext uri="{BB962C8B-B14F-4D97-AF65-F5344CB8AC3E}">
+        <p14:creationId xmlns:p14="http://schemas.microsoft.com/office/powerpoint/2010/main" val="740217281"/>
+      </p:ext>
+    </p:extLst>
+  </p:cSld>
+  <p:clrMapOvr>
+    <a:masterClrMapping/>
+  </p:clrMapOvr>
+</p:sld>
+</file>
+
+<file path=ppt/slides/slide14.xml><?xml version="1.0" encoding="utf-8"?>
 <p:sld xmlns:a="http://schemas.openxmlformats.org/drawingml/2006/main" xmlns:r="http://schemas.openxmlformats.org/officeDocument/2006/relationships" xmlns:p="http://schemas.openxmlformats.org/presentationml/2006/main">
   <p:cSld>
     <p:spTree>
@@ -26976,7 +28693,7 @@
 
 <file path=ppt/webextensions/taskpanes.xml><?xml version="1.0" encoding="utf-8"?>
 <wetp:taskpanes xmlns:wetp="http://schemas.microsoft.com/office/webextensions/taskpanes/2010/11">
-  <wetp:taskpane dockstate="right" visibility="0" width="350" row="2">
+  <wetp:taskpane dockstate="right" visibility="0" width="677" row="1">
     <wetp:webextensionref xmlns:r="http://schemas.openxmlformats.org/officeDocument/2006/relationships" r:id="rId1"/>
   </wetp:taskpane>
 </wetp:taskpanes>

</xml_diff>

<commit_message>
Open AI Example changes
</commit_message>
<xml_diff>
--- a/Microsoft Agent Framework.pptx
+++ b/Microsoft Agent Framework.pptx
@@ -14067,7 +14067,25 @@
                 </a:solidFill>
                 <a:latin typeface="Calibri" pitchFamily="34" charset="0"/>
               </a:rPr>
-              <a:t>A folder of instructions, scripts, and resources an agent discovers and loads on demand — once built, reusable across any compatible agent product.</a:t>
+              <a:t>Agent Skills are a lightweight, open format for extending AI agent capabilities with </a:t>
+            </a:r>
+            <a:r>
+              <a:rPr lang="en-US" sz="1000" dirty="0" err="1">
+                <a:solidFill>
+                  <a:srgbClr val="4A5568"/>
+                </a:solidFill>
+                <a:latin typeface="Calibri" pitchFamily="34" charset="0"/>
+              </a:rPr>
+              <a:t>specialised</a:t>
+            </a:r>
+            <a:r>
+              <a:rPr lang="en-US" sz="1000" dirty="0">
+                <a:solidFill>
+                  <a:srgbClr val="4A5568"/>
+                </a:solidFill>
+                <a:latin typeface="Calibri" pitchFamily="34" charset="0"/>
+              </a:rPr>
+              <a:t> knowledge and workflows. A folder of instructions, scripts, and resources that an agent discovers and loads on demand — once built, reusable across any compatible agent product.</a:t>
             </a:r>
           </a:p>
           <a:p>
@@ -14190,6 +14208,7 @@
           <a:ln>
             <a:noFill/>
           </a:ln>
+          <a:effectLst/>
         </p:spPr>
         <p:txBody>
           <a:bodyPr vert="horz" lIns="91440" tIns="45720" rIns="91440" bIns="45720" anchor="ctr"/>
@@ -14508,7 +14527,7 @@
         <p:spPr>
           <a:xfrm>
             <a:off x="342900" y="4254500"/>
-            <a:ext cx="5588000" cy="1206500"/>
+            <a:ext cx="3534156" cy="1206500"/>
           </a:xfrm>
           <a:prstGeom prst="rect">
             <a:avLst/>
@@ -14539,7 +14558,7 @@
         <p:spPr>
           <a:xfrm>
             <a:off x="393700" y="4254500"/>
-            <a:ext cx="5486400" cy="63500"/>
+            <a:ext cx="3469899" cy="63500"/>
           </a:xfrm>
           <a:prstGeom prst="rect">
             <a:avLst/>
@@ -14607,7 +14626,7 @@
         <p:spPr>
           <a:xfrm>
             <a:off x="508000" y="4711700"/>
-            <a:ext cx="5245100" cy="673100"/>
+            <a:ext cx="3355599" cy="673100"/>
           </a:xfrm>
           <a:prstGeom prst="rect">
             <a:avLst/>
@@ -14686,8 +14705,8 @@
         </p:nvSpPr>
         <p:spPr>
           <a:xfrm>
-            <a:off x="6261100" y="4254500"/>
-            <a:ext cx="5588000" cy="1206500"/>
+            <a:off x="3949700" y="4264152"/>
+            <a:ext cx="3534156" cy="1206500"/>
           </a:xfrm>
           <a:prstGeom prst="rect">
             <a:avLst/>
@@ -14717,8 +14736,8 @@
         </p:nvSpPr>
         <p:spPr>
           <a:xfrm>
-            <a:off x="6311900" y="4254500"/>
-            <a:ext cx="5486400" cy="63500"/>
+            <a:off x="3956812" y="4264152"/>
+            <a:ext cx="3534156" cy="45719"/>
           </a:xfrm>
           <a:prstGeom prst="rect">
             <a:avLst/>
@@ -14748,8 +14767,8 @@
         </p:nvSpPr>
         <p:spPr>
           <a:xfrm>
-            <a:off x="6438900" y="4406900"/>
-            <a:ext cx="5245100" cy="254000"/>
+            <a:off x="4127500" y="4416552"/>
+            <a:ext cx="3269996" cy="254000"/>
           </a:xfrm>
           <a:prstGeom prst="rect">
             <a:avLst/>
@@ -14785,8 +14804,8 @@
         </p:nvSpPr>
         <p:spPr>
           <a:xfrm>
-            <a:off x="6438900" y="4711700"/>
-            <a:ext cx="5245100" cy="673100"/>
+            <a:off x="4127500" y="4721352"/>
+            <a:ext cx="3269996" cy="673100"/>
           </a:xfrm>
           <a:prstGeom prst="rect">
             <a:avLst/>
@@ -15519,6 +15538,205 @@
                 <a:latin typeface="Calibri" pitchFamily="34" charset="0"/>
               </a:rPr>
               <a:t>Agents: extend capabilities on demand, keep context lean</a:t>
+            </a:r>
+          </a:p>
+        </p:txBody>
+      </p:sp>
+      <p:sp>
+        <p:nvSpPr>
+          <p:cNvPr id="9" name="WireBg">
+            <a:extLst>
+              <a:ext uri="{FF2B5EF4-FFF2-40B4-BE49-F238E27FC236}">
+                <a16:creationId xmlns:a16="http://schemas.microsoft.com/office/drawing/2014/main" id="{CDA53953-F4BD-EB4B-C2A2-5F1804CAF8B6}"/>
+              </a:ext>
+            </a:extLst>
+          </p:cNvPr>
+          <p:cNvSpPr>
+            <a:spLocks noGrp="1"/>
+          </p:cNvSpPr>
+          <p:nvPr/>
+        </p:nvSpPr>
+        <p:spPr>
+          <a:xfrm>
+            <a:off x="7668768" y="4270756"/>
+            <a:ext cx="3534156" cy="1206500"/>
+          </a:xfrm>
+          <a:prstGeom prst="rect">
+            <a:avLst/>
+          </a:prstGeom>
+          <a:solidFill>
+            <a:srgbClr val="F0F5FA"/>
+          </a:solidFill>
+          <a:ln>
+            <a:noFill/>
+          </a:ln>
+        </p:spPr>
+        <p:txBody>
+          <a:bodyPr vert="horz" lIns="91440" tIns="45720" rIns="91440" bIns="45720" anchor="ctr"/>
+          <a:lstStyle/>
+          <a:p>
+            <a:endParaRPr lang="en-US" dirty="0"/>
+          </a:p>
+        </p:txBody>
+      </p:sp>
+      <p:sp>
+        <p:nvSpPr>
+          <p:cNvPr id="10" name="WireAccent">
+            <a:extLst>
+              <a:ext uri="{FF2B5EF4-FFF2-40B4-BE49-F238E27FC236}">
+                <a16:creationId xmlns:a16="http://schemas.microsoft.com/office/drawing/2014/main" id="{FAF633CF-1095-31B5-5601-2C20A9D04E72}"/>
+              </a:ext>
+            </a:extLst>
+          </p:cNvPr>
+          <p:cNvSpPr>
+            <a:spLocks noGrp="1"/>
+          </p:cNvSpPr>
+          <p:nvPr/>
+        </p:nvSpPr>
+        <p:spPr>
+          <a:xfrm>
+            <a:off x="7675880" y="4270756"/>
+            <a:ext cx="3534156" cy="45719"/>
+          </a:xfrm>
+          <a:prstGeom prst="rect">
+            <a:avLst/>
+          </a:prstGeom>
+          <a:solidFill>
+            <a:schemeClr val="accent3">
+              <a:lumMod val="20000"/>
+              <a:lumOff val="80000"/>
+            </a:schemeClr>
+          </a:solidFill>
+          <a:ln>
+            <a:noFill/>
+          </a:ln>
+        </p:spPr>
+        <p:txBody>
+          <a:bodyPr vert="horz" lIns="91440" tIns="45720" rIns="91440" bIns="45720" anchor="ctr"/>
+          <a:lstStyle/>
+          <a:p>
+            <a:endParaRPr lang="en-US" dirty="0"/>
+          </a:p>
+        </p:txBody>
+      </p:sp>
+      <p:sp>
+        <p:nvSpPr>
+          <p:cNvPr id="11" name="WireTitle">
+            <a:extLst>
+              <a:ext uri="{FF2B5EF4-FFF2-40B4-BE49-F238E27FC236}">
+                <a16:creationId xmlns:a16="http://schemas.microsoft.com/office/drawing/2014/main" id="{E50DDCC4-D089-BBDF-10D5-08CE1481266A}"/>
+              </a:ext>
+            </a:extLst>
+          </p:cNvPr>
+          <p:cNvSpPr>
+            <a:spLocks noGrp="1"/>
+          </p:cNvSpPr>
+          <p:nvPr/>
+        </p:nvSpPr>
+        <p:spPr>
+          <a:xfrm>
+            <a:off x="7800848" y="4394200"/>
+            <a:ext cx="3269996" cy="254000"/>
+          </a:xfrm>
+          <a:prstGeom prst="rect">
+            <a:avLst/>
+          </a:prstGeom>
+          <a:noFill/>
+          <a:ln>
+            <a:noFill/>
+          </a:ln>
+        </p:spPr>
+        <p:txBody>
+          <a:bodyPr vert="horz" lIns="91440" tIns="45720" rIns="91440" bIns="45720" anchor="ctr"/>
+          <a:lstStyle/>
+          <a:p>
+            <a:r>
+              <a:rPr lang="en-US" sz="1467" b="1" dirty="0">
+                <a:solidFill>
+                  <a:srgbClr val="0F1F3D"/>
+                </a:solidFill>
+                <a:latin typeface="Calibri" pitchFamily="34" charset="0"/>
+              </a:rPr>
+              <a:t>Skill Composition</a:t>
+            </a:r>
+          </a:p>
+        </p:txBody>
+      </p:sp>
+      <p:sp>
+        <p:nvSpPr>
+          <p:cNvPr id="6" name="TextBox 5">
+            <a:extLst>
+              <a:ext uri="{FF2B5EF4-FFF2-40B4-BE49-F238E27FC236}">
+                <a16:creationId xmlns:a16="http://schemas.microsoft.com/office/drawing/2014/main" id="{F3E9EF72-96B0-8619-8C25-0D3B62C59FE0}"/>
+              </a:ext>
+            </a:extLst>
+          </p:cNvPr>
+          <p:cNvSpPr txBox="1"/>
+          <p:nvPr/>
+        </p:nvSpPr>
+        <p:spPr>
+          <a:xfrm>
+            <a:off x="7835900" y="4598705"/>
+            <a:ext cx="3280664" cy="915635"/>
+          </a:xfrm>
+          <a:prstGeom prst="rect">
+            <a:avLst/>
+          </a:prstGeom>
+          <a:noFill/>
+        </p:spPr>
+        <p:txBody>
+          <a:bodyPr wrap="square">
+            <a:spAutoFit/>
+          </a:bodyPr>
+          <a:lstStyle/>
+          <a:p>
+            <a:r>
+              <a:rPr lang="en-IN" sz="1070" dirty="0">
+                <a:latin typeface="Calibri" panose="020F0502020204030204" pitchFamily="34" charset="0"/>
+                <a:ea typeface="Calibri" panose="020F0502020204030204" pitchFamily="34" charset="0"/>
+                <a:cs typeface="Calibri" panose="020F0502020204030204" pitchFamily="34" charset="0"/>
+              </a:rPr>
+              <a:t>my-skill/</a:t>
+            </a:r>
+          </a:p>
+          <a:p>
+            <a:r>
+              <a:rPr lang="en-IN" sz="1070" dirty="0">
+                <a:latin typeface="Calibri" panose="020F0502020204030204" pitchFamily="34" charset="0"/>
+                <a:ea typeface="Calibri" panose="020F0502020204030204" pitchFamily="34" charset="0"/>
+                <a:cs typeface="Calibri" panose="020F0502020204030204" pitchFamily="34" charset="0"/>
+              </a:rPr>
+              <a:t>├── SKILL.md          # Required: instructions + metadata</a:t>
+            </a:r>
+          </a:p>
+          <a:p>
+            <a:r>
+              <a:rPr lang="en-IN" sz="1070" dirty="0">
+                <a:latin typeface="Calibri" panose="020F0502020204030204" pitchFamily="34" charset="0"/>
+                <a:ea typeface="Calibri" panose="020F0502020204030204" pitchFamily="34" charset="0"/>
+                <a:cs typeface="Calibri" panose="020F0502020204030204" pitchFamily="34" charset="0"/>
+              </a:rPr>
+              <a:t>├── scripts/          # Optional: executable code</a:t>
+            </a:r>
+          </a:p>
+          <a:p>
+            <a:r>
+              <a:rPr lang="en-IN" sz="1070" dirty="0">
+                <a:latin typeface="Calibri" panose="020F0502020204030204" pitchFamily="34" charset="0"/>
+                <a:ea typeface="Calibri" panose="020F0502020204030204" pitchFamily="34" charset="0"/>
+                <a:cs typeface="Calibri" panose="020F0502020204030204" pitchFamily="34" charset="0"/>
+              </a:rPr>
+              <a:t>├── references/       # Optional: documentation</a:t>
+            </a:r>
+          </a:p>
+          <a:p>
+            <a:r>
+              <a:rPr lang="en-IN" sz="1070" dirty="0">
+                <a:latin typeface="Calibri" panose="020F0502020204030204" pitchFamily="34" charset="0"/>
+                <a:ea typeface="Calibri" panose="020F0502020204030204" pitchFamily="34" charset="0"/>
+                <a:cs typeface="Calibri" panose="020F0502020204030204" pitchFamily="34" charset="0"/>
+              </a:rPr>
+              <a:t>└── assets/           # Optional: templates, resources</a:t>
             </a:r>
           </a:p>
         </p:txBody>
@@ -23259,7 +23477,7 @@
                 </a:solidFill>
                 <a:latin typeface="Calibri" pitchFamily="34" charset="0"/>
               </a:rPr>
-              <a:t> — swap GPT → Gemini → Claude with zero code changes</a:t>
+              <a:t> — swap GPT → Gemini → Claude with zero code or minimal code changes</a:t>
             </a:r>
           </a:p>
         </p:txBody>
@@ -32638,7 +32856,29 @@
                 <a:ea typeface="Calibri" pitchFamily="34" charset="-122"/>
                 <a:cs typeface="Calibri" pitchFamily="34" charset="-120"/>
               </a:rPr>
-              <a:t>Manages multi-turn conversation state. Persist to disk, Cosmos DB, or any IChatMessageStore. Pass the same thread across calls to maintain memory.</a:t>
+              <a:t>Manages multi-turn conversation state. Persist to disk, Cosmos DB, or any </a:t>
+            </a:r>
+            <a:r>
+              <a:rPr lang="en-US" sz="1307" dirty="0" err="1">
+                <a:solidFill>
+                  <a:srgbClr val="4A5568"/>
+                </a:solidFill>
+                <a:latin typeface="Calibri" pitchFamily="34" charset="0"/>
+                <a:ea typeface="Calibri" pitchFamily="34" charset="-122"/>
+                <a:cs typeface="Calibri" pitchFamily="34" charset="-120"/>
+              </a:rPr>
+              <a:t>MessageStore</a:t>
+            </a:r>
+            <a:r>
+              <a:rPr lang="en-US" sz="1307" dirty="0">
+                <a:solidFill>
+                  <a:srgbClr val="4A5568"/>
+                </a:solidFill>
+                <a:latin typeface="Calibri" pitchFamily="34" charset="0"/>
+                <a:ea typeface="Calibri" pitchFamily="34" charset="-122"/>
+                <a:cs typeface="Calibri" pitchFamily="34" charset="-120"/>
+              </a:rPr>
+              <a:t>. Pass the same Session across calls to maintain memory.</a:t>
             </a:r>
             <a:endParaRPr lang="en-US" sz="1307" dirty="0">
               <a:solidFill>
@@ -32829,7 +33069,7 @@
         </p:nvSpPr>
         <p:spPr>
           <a:xfrm>
-            <a:off x="512064" y="5279136"/>
+            <a:off x="512064" y="5205984"/>
             <a:ext cx="3194304" cy="1219200"/>
           </a:xfrm>
           <a:prstGeom prst="rect">
@@ -32852,7 +33092,7 @@
                 <a:ea typeface="Calibri" pitchFamily="34" charset="-122"/>
                 <a:cs typeface="Calibri" pitchFamily="34" charset="-120"/>
               </a:rPr>
-              <a:t>C# methods decorated with [AgentTool] or created via AIFunctionFactory.Create(). MCP servers auto-register as tools. LLM invokes them automatically.</a:t>
+              <a:t>C# methods and arguments decorated with [Description] or created via AIFunctionFactory.Create(). MCP servers auto-register as tools. LLM invokes them automatically.</a:t>
             </a:r>
             <a:endParaRPr lang="en-US" sz="1307" dirty="0">
               <a:solidFill>

</xml_diff>